<commit_message>
add SoftCom paper draft and update advisor presentation with Exp 1+2 results
Paper (a-sofctom.tex):
- Full 6-page IEEE rewrite with actual experimental results
- 27 citations, 6 tables, algorithm block with self-cancellation proof
- Key findings: Chebyshev self-cancels, guard n<3 is bottleneck,
  Welford alone worsens (coupled adaptations), r0 not robust
- Exp 3 baseline results: placeholder (running on Linux)
- 17 new BibTeX entries in referencias.bib

Presentation (2026-04-17-main-advisor):
- Slide 8: Exp 1+2 results (sweep + ablation) with actual numbers
- Slide 9: updated decisions reflecting new findings
- Speaker notes + emergency card updated with 5 new key facts

Co-Authored-By: Claude Opus 4.6 (1M context) <noreply@anthropic.com>
</commit_message>
<xml_diff>
--- a/docs/meeting/2026-04-17-main-advisor/2026-04-17-main-advisor.pptx
+++ b/docs/meeting/2026-04-17-main-advisor/2026-04-17-main-advisor.pptx
@@ -7682,567 +7682,56 @@
               </a:defRPr>
             </a:pPr>
             <a:r>
-              <a:t>Proximos Experimentos — Priorizacao</a:t>
-            </a:r>
-          </a:p>
-        </p:txBody>
-      </p:sp>
-      <p:graphicFrame>
-        <p:nvGraphicFramePr>
-          <p:cNvPr id="4" name="Table 3"/>
-          <p:cNvGraphicFramePr>
-            <a:graphicFrameLocks noGrp="1"/>
-          </p:cNvGraphicFramePr>
+              <a:t>Resultados Novos (Exp 1 + Exp 2)</a:t>
+            </a:r>
+          </a:p>
+        </p:txBody>
+      </p:sp>
+      <p:sp>
+        <p:nvSpPr>
+          <p:cNvPr id="4" name="Rounded Rectangle 3"/>
+          <p:cNvSpPr/>
           <p:nvPr/>
-        </p:nvGraphicFramePr>
-        <p:xfrm>
-          <a:off x="274320" y="1371600"/>
-          <a:ext cx="11612880" cy="4114800"/>
-        </p:xfrm>
-        <a:graphic>
-          <a:graphicData uri="http://schemas.openxmlformats.org/drawingml/2006/table">
-            <a:tbl>
-              <a:tblPr firstRow="1" bandRow="1">
-                <a:tableStyleId>{5C22544A-7EE6-4342-B048-85BDC9FD1C3A}</a:tableStyleId>
-              </a:tblPr>
-              <a:tblGrid>
-                <a:gridCol w="2903220"/>
-                <a:gridCol w="2903220"/>
-                <a:gridCol w="2903220"/>
-                <a:gridCol w="2903220"/>
-              </a:tblGrid>
-              <a:tr h="685800">
-                <a:tc>
-                  <a:txBody>
-                    <a:bodyPr/>
-                    <a:lstStyle/>
-                    <a:p>
-                      <a:pPr>
-                        <a:defRPr b="1" sz="1400">
-                          <a:solidFill>
-                            <a:srgbClr val="FFFFFF"/>
-                          </a:solidFill>
-                          <a:latin typeface="Calibri"/>
-                        </a:defRPr>
-                      </a:pPr>
-                      <a:r>
-                        <a:t>Prioridade</a:t>
-                      </a:r>
-                    </a:p>
-                  </a:txBody>
-                  <a:tcPr>
-                    <a:solidFill>
-                      <a:srgbClr val="1B3A5C"/>
-                    </a:solidFill>
-                  </a:tcPr>
-                </a:tc>
-                <a:tc>
-                  <a:txBody>
-                    <a:bodyPr/>
-                    <a:lstStyle/>
-                    <a:p>
-                      <a:pPr>
-                        <a:defRPr b="1" sz="1400">
-                          <a:solidFill>
-                            <a:srgbClr val="FFFFFF"/>
-                          </a:solidFill>
-                          <a:latin typeface="Calibri"/>
-                        </a:defRPr>
-                      </a:pPr>
-                      <a:r>
-                        <a:t>Experimento</a:t>
-                      </a:r>
-                    </a:p>
-                  </a:txBody>
-                  <a:tcPr>
-                    <a:solidFill>
-                      <a:srgbClr val="1B3A5C"/>
-                    </a:solidFill>
-                  </a:tcPr>
-                </a:tc>
-                <a:tc>
-                  <a:txBody>
-                    <a:bodyPr/>
-                    <a:lstStyle/>
-                    <a:p>
-                      <a:pPr>
-                        <a:defRPr b="1" sz="1400">
-                          <a:solidFill>
-                            <a:srgbClr val="FFFFFF"/>
-                          </a:solidFill>
-                          <a:latin typeface="Calibri"/>
-                        </a:defRPr>
-                      </a:pPr>
-                      <a:r>
-                        <a:t>Tempo</a:t>
-                      </a:r>
-                    </a:p>
-                  </a:txBody>
-                  <a:tcPr>
-                    <a:solidFill>
-                      <a:srgbClr val="1B3A5C"/>
-                    </a:solidFill>
-                  </a:tcPr>
-                </a:tc>
-                <a:tc>
-                  <a:txBody>
-                    <a:bodyPr/>
-                    <a:lstStyle/>
-                    <a:p>
-                      <a:pPr>
-                        <a:defRPr b="1" sz="1400">
-                          <a:solidFill>
-                            <a:srgbClr val="FFFFFF"/>
-                          </a:solidFill>
-                          <a:latin typeface="Calibri"/>
-                        </a:defRPr>
-                      </a:pPr>
-                      <a:r>
-                        <a:t>Produz</a:t>
-                      </a:r>
-                    </a:p>
-                  </a:txBody>
-                  <a:tcPr>
-                    <a:solidFill>
-                      <a:srgbClr val="1B3A5C"/>
-                    </a:solidFill>
-                  </a:tcPr>
-                </a:tc>
-              </a:tr>
-              <a:tr h="685800">
-                <a:tc>
-                  <a:txBody>
-                    <a:bodyPr/>
-                    <a:lstStyle/>
-                    <a:p>
-                      <a:pPr algn="ctr">
-                        <a:defRPr sz="1300" b="1" i="0">
-                          <a:solidFill>
-                            <a:srgbClr val="E74C3C"/>
-                          </a:solidFill>
-                          <a:latin typeface="Calibri"/>
-                        </a:defRPr>
-                      </a:pPr>
-                      <a:r>
-                        <a:t>[ALTA]</a:t>
-                      </a:r>
-                    </a:p>
-                  </a:txBody>
-                  <a:tcPr anchor="ctr">
-                    <a:solidFill>
-                      <a:srgbClr val="FDEDED"/>
-                    </a:solidFill>
-                  </a:tcPr>
-                </a:tc>
-                <a:tc>
-                  <a:txBody>
-                    <a:bodyPr/>
-                    <a:lstStyle/>
-                    <a:p>
-                      <a:pPr algn="l">
-                        <a:defRPr sz="1200" b="0" i="0">
-                          <a:solidFill>
-                            <a:srgbClr val="000000"/>
-                          </a:solidFill>
-                          <a:latin typeface="Calibri"/>
-                        </a:defRPr>
-                      </a:pPr>
-                      <a:r>
-                        <a:t>Sweep dimensional d∈{2,5,10,17,20,50}</a:t>
-                      </a:r>
-                    </a:p>
-                  </a:txBody>
-                  <a:tcPr anchor="ctr"/>
-                </a:tc>
-                <a:tc>
-                  <a:txBody>
-                    <a:bodyPr/>
-                    <a:lstStyle/>
-                    <a:p>
-                      <a:pPr algn="ctr">
-                        <a:defRPr sz="1200" b="0" i="0">
-                          <a:solidFill>
-                            <a:srgbClr val="000000"/>
-                          </a:solidFill>
-                          <a:latin typeface="Calibri"/>
-                        </a:defRPr>
-                      </a:pPr>
-                      <a:r>
-                        <a:t>2-3 dias</a:t>
-                      </a:r>
-                    </a:p>
-                  </a:txBody>
-                  <a:tcPr anchor="ctr"/>
-                </a:tc>
-                <a:tc>
-                  <a:txBody>
-                    <a:bodyPr/>
-                    <a:lstStyle/>
-                    <a:p>
-                      <a:pPr algn="l">
-                        <a:defRPr sz="1200" b="0" i="0">
-                          <a:solidFill>
-                            <a:srgbClr val="000000"/>
-                          </a:solidFill>
-                          <a:latin typeface="Calibri"/>
-                        </a:defRPr>
-                      </a:pPr>
-                      <a:r>
-                        <a:t>Curva de colapso (fig. paper)</a:t>
-                      </a:r>
-                    </a:p>
-                  </a:txBody>
-                  <a:tcPr anchor="ctr"/>
-                </a:tc>
-              </a:tr>
-              <a:tr h="685800">
-                <a:tc>
-                  <a:txBody>
-                    <a:bodyPr/>
-                    <a:lstStyle/>
-                    <a:p>
-                      <a:pPr algn="ctr">
-                        <a:defRPr sz="1300" b="1" i="0">
-                          <a:solidFill>
-                            <a:srgbClr val="E74C3C"/>
-                          </a:solidFill>
-                          <a:latin typeface="Calibri"/>
-                        </a:defRPr>
-                      </a:pPr>
-                      <a:r>
-                        <a:t>[ALTA]</a:t>
-                      </a:r>
-                    </a:p>
-                  </a:txBody>
-                  <a:tcPr anchor="ctr">
-                    <a:solidFill>
-                      <a:srgbClr val="FDEDED"/>
-                    </a:solidFill>
-                  </a:tcPr>
-                </a:tc>
-                <a:tc>
-                  <a:txBody>
-                    <a:bodyPr/>
-                    <a:lstStyle/>
-                    <a:p>
-                      <a:pPr algn="l">
-                        <a:defRPr sz="1200" b="0" i="0">
-                          <a:solidFill>
-                            <a:srgbClr val="000000"/>
-                          </a:solidFill>
-                          <a:latin typeface="Calibri"/>
-                        </a:defRPr>
-                      </a:pPr>
-                      <a:r>
-                        <a:t>Ablation V0-V7 (8 variantes)</a:t>
-                      </a:r>
-                    </a:p>
-                  </a:txBody>
-                  <a:tcPr anchor="ctr"/>
-                </a:tc>
-                <a:tc>
-                  <a:txBody>
-                    <a:bodyPr/>
-                    <a:lstStyle/>
-                    <a:p>
-                      <a:pPr algn="ctr">
-                        <a:defRPr sz="1200" b="0" i="0">
-                          <a:solidFill>
-                            <a:srgbClr val="000000"/>
-                          </a:solidFill>
-                          <a:latin typeface="Calibri"/>
-                        </a:defRPr>
-                      </a:pPr>
-                      <a:r>
-                        <a:t>2-3 dias</a:t>
-                      </a:r>
-                    </a:p>
-                  </a:txBody>
-                  <a:tcPr anchor="ctr"/>
-                </a:tc>
-                <a:tc>
-                  <a:txBody>
-                    <a:bodyPr/>
-                    <a:lstStyle/>
-                    <a:p>
-                      <a:pPr algn="l">
-                        <a:defRPr sz="1200" b="0" i="0">
-                          <a:solidFill>
-                            <a:srgbClr val="000000"/>
-                          </a:solidFill>
-                          <a:latin typeface="Calibri"/>
-                        </a:defRPr>
-                      </a:pPr>
-                      <a:r>
-                        <a:t>Contribuicao isolada de cada fix</a:t>
-                      </a:r>
-                    </a:p>
-                  </a:txBody>
-                  <a:tcPr anchor="ctr"/>
-                </a:tc>
-              </a:tr>
-              <a:tr h="685800">
-                <a:tc>
-                  <a:txBody>
-                    <a:bodyPr/>
-                    <a:lstStyle/>
-                    <a:p>
-                      <a:pPr algn="ctr">
-                        <a:defRPr sz="1300" b="1" i="0">
-                          <a:solidFill>
-                            <a:srgbClr val="F39C12"/>
-                          </a:solidFill>
-                          <a:latin typeface="Calibri"/>
-                        </a:defRPr>
-                      </a:pPr>
-                      <a:r>
-                        <a:t>[MEDIA]</a:t>
-                      </a:r>
-                    </a:p>
-                  </a:txBody>
-                  <a:tcPr anchor="ctr">
-                    <a:solidFill>
-                      <a:srgbClr val="FFF8E1"/>
-                    </a:solidFill>
-                  </a:tcPr>
-                </a:tc>
-                <a:tc>
-                  <a:txBody>
-                    <a:bodyPr/>
-                    <a:lstStyle/>
-                    <a:p>
-                      <a:pPr algn="l">
-                        <a:defRPr sz="1200" b="0" i="0">
-                          <a:solidFill>
-                            <a:srgbClr val="000000"/>
-                          </a:solidFill>
-                          <a:latin typeface="Calibri"/>
-                        </a:defRPr>
-                      </a:pPr>
-                      <a:r>
-                        <a:t>S5 Two-Stage (per-flow → concentracao IP)</a:t>
-                      </a:r>
-                    </a:p>
-                  </a:txBody>
-                  <a:tcPr anchor="ctr"/>
-                </a:tc>
-                <a:tc>
-                  <a:txBody>
-                    <a:bodyPr/>
-                    <a:lstStyle/>
-                    <a:p>
-                      <a:pPr algn="ctr">
-                        <a:defRPr sz="1200" b="0" i="0">
-                          <a:solidFill>
-                            <a:srgbClr val="000000"/>
-                          </a:solidFill>
-                          <a:latin typeface="Calibri"/>
-                        </a:defRPr>
-                      </a:pPr>
-                      <a:r>
-                        <a:t>3-5 dias</a:t>
-                      </a:r>
-                    </a:p>
-                  </a:txBody>
-                  <a:tcPr anchor="ctr"/>
-                </a:tc>
-                <a:tc>
-                  <a:txBody>
-                    <a:bodyPr/>
-                    <a:lstStyle/>
-                    <a:p>
-                      <a:pPr algn="l">
-                        <a:defRPr sz="1200" b="0" i="0">
-                          <a:solidFill>
-                            <a:srgbClr val="000000"/>
-                          </a:solidFill>
-                          <a:latin typeface="Calibri"/>
-                        </a:defRPr>
-                      </a:pPr>
-                      <a:r>
-                        <a:t>Ataca trade-off FPR/Recall</a:t>
-                      </a:r>
-                    </a:p>
-                  </a:txBody>
-                  <a:tcPr anchor="ctr"/>
-                </a:tc>
-              </a:tr>
-              <a:tr h="685800">
-                <a:tc>
-                  <a:txBody>
-                    <a:bodyPr/>
-                    <a:lstStyle/>
-                    <a:p>
-                      <a:pPr algn="ctr">
-                        <a:defRPr sz="1300" b="1" i="0">
-                          <a:solidFill>
-                            <a:srgbClr val="F39C12"/>
-                          </a:solidFill>
-                          <a:latin typeface="Calibri"/>
-                        </a:defRPr>
-                      </a:pPr>
-                      <a:r>
-                        <a:t>[MEDIA]</a:t>
-                      </a:r>
-                    </a:p>
-                  </a:txBody>
-                  <a:tcPr anchor="ctr">
-                    <a:solidFill>
-                      <a:srgbClr val="FFF8E1"/>
-                    </a:solidFill>
-                  </a:tcPr>
-                </a:tc>
-                <a:tc>
-                  <a:txBody>
-                    <a:bodyPr/>
-                    <a:lstStyle/>
-                    <a:p>
-                      <a:pPr algn="l">
-                        <a:defRPr sz="1200" b="0" i="0">
-                          <a:solidFill>
-                            <a:srgbClr val="000000"/>
-                          </a:solidFill>
-                          <a:latin typeface="Calibri"/>
-                        </a:defRPr>
-                      </a:pPr>
-                      <a:r>
-                        <a:t>Baseline IF/OC-SVM prequential</a:t>
-                      </a:r>
-                    </a:p>
-                  </a:txBody>
-                  <a:tcPr anchor="ctr"/>
-                </a:tc>
-                <a:tc>
-                  <a:txBody>
-                    <a:bodyPr/>
-                    <a:lstStyle/>
-                    <a:p>
-                      <a:pPr algn="ctr">
-                        <a:defRPr sz="1200" b="0" i="0">
-                          <a:solidFill>
-                            <a:srgbClr val="000000"/>
-                          </a:solidFill>
-                          <a:latin typeface="Calibri"/>
-                        </a:defRPr>
-                      </a:pPr>
-                      <a:r>
-                        <a:t>1-2 dias</a:t>
-                      </a:r>
-                    </a:p>
-                  </a:txBody>
-                  <a:tcPr anchor="ctr"/>
-                </a:tc>
-                <a:tc>
-                  <a:txBody>
-                    <a:bodyPr/>
-                    <a:lstStyle/>
-                    <a:p>
-                      <a:pPr algn="l">
-                        <a:defRPr sz="1200" b="0" i="0">
-                          <a:solidFill>
-                            <a:srgbClr val="000000"/>
-                          </a:solidFill>
-                          <a:latin typeface="Calibri"/>
-                        </a:defRPr>
-                      </a:pPr>
-                      <a:r>
-                        <a:t>Comparacao direta</a:t>
-                      </a:r>
-                    </a:p>
-                  </a:txBody>
-                  <a:tcPr anchor="ctr"/>
-                </a:tc>
-              </a:tr>
-              <a:tr h="685800">
-                <a:tc>
-                  <a:txBody>
-                    <a:bodyPr/>
-                    <a:lstStyle/>
-                    <a:p>
-                      <a:pPr algn="ctr">
-                        <a:defRPr sz="1300" b="1" i="0">
-                          <a:solidFill>
-                            <a:srgbClr val="27AE60"/>
-                          </a:solidFill>
-                          <a:latin typeface="Calibri"/>
-                        </a:defRPr>
-                      </a:pPr>
-                      <a:r>
-                        <a:t>[BAIXA]</a:t>
-                      </a:r>
-                    </a:p>
-                  </a:txBody>
-                  <a:tcPr anchor="ctr">
-                    <a:solidFill>
-                      <a:srgbClr val="E8F5E9"/>
-                    </a:solidFill>
-                  </a:tcPr>
-                </a:tc>
-                <a:tc>
-                  <a:txBody>
-                    <a:bodyPr/>
-                    <a:lstStyle/>
-                    <a:p>
-                      <a:pPr algn="l">
-                        <a:defRPr sz="1200" b="0" i="0">
-                          <a:solidFill>
-                            <a:srgbClr val="000000"/>
-                          </a:solidFill>
-                          <a:latin typeface="Calibri"/>
-                        </a:defRPr>
-                      </a:pPr>
-                      <a:r>
-                        <a:t>KS-test + Spearman</a:t>
-                      </a:r>
-                    </a:p>
-                  </a:txBody>
-                  <a:tcPr anchor="ctr"/>
-                </a:tc>
-                <a:tc>
-                  <a:txBody>
-                    <a:bodyPr/>
-                    <a:lstStyle/>
-                    <a:p>
-                      <a:pPr algn="ctr">
-                        <a:defRPr sz="1200" b="0" i="0">
-                          <a:solidFill>
-                            <a:srgbClr val="000000"/>
-                          </a:solidFill>
-                          <a:latin typeface="Calibri"/>
-                        </a:defRPr>
-                      </a:pPr>
-                      <a:r>
-                        <a:t>2-3 dias</a:t>
-                      </a:r>
-                    </a:p>
-                  </a:txBody>
-                  <a:tcPr anchor="ctr"/>
-                </a:tc>
-                <a:tc>
-                  <a:txBody>
-                    <a:bodyPr/>
-                    <a:lstStyle/>
-                    <a:p>
-                      <a:pPr algn="l">
-                        <a:defRPr sz="1200" b="0" i="0">
-                          <a:solidFill>
-                            <a:srgbClr val="000000"/>
-                          </a:solidFill>
-                          <a:latin typeface="Calibri"/>
-                        </a:defRPr>
-                      </a:pPr>
-                      <a:r>
-                        <a:t>Valida dim. anomalas</a:t>
-                      </a:r>
-                    </a:p>
-                  </a:txBody>
-                  <a:tcPr anchor="ctr"/>
-                </a:tc>
-              </a:tr>
-            </a:tbl>
-          </a:graphicData>
-        </a:graphic>
-      </p:graphicFrame>
+        </p:nvSpPr>
+        <p:spPr>
+          <a:xfrm>
+            <a:off x="274320" y="1371600"/>
+            <a:ext cx="5760720" cy="3200400"/>
+          </a:xfrm>
+          <a:prstGeom prst="roundRect">
+            <a:avLst/>
+          </a:prstGeom>
+          <a:solidFill>
+            <a:srgbClr val="E8F5E9"/>
+          </a:solidFill>
+          <a:ln w="19050">
+            <a:solidFill>
+              <a:srgbClr val="27AE60"/>
+            </a:solidFill>
+          </a:ln>
+        </p:spPr>
+        <p:style>
+          <a:lnRef idx="1">
+            <a:schemeClr val="accent1"/>
+          </a:lnRef>
+          <a:fillRef idx="3">
+            <a:schemeClr val="accent1"/>
+          </a:fillRef>
+          <a:effectRef idx="2">
+            <a:schemeClr val="accent1"/>
+          </a:effectRef>
+          <a:fontRef idx="minor">
+            <a:schemeClr val="lt1"/>
+          </a:fontRef>
+        </p:style>
+        <p:txBody>
+          <a:bodyPr rtlCol="0" anchor="ctr"/>
+          <a:lstStyle/>
+          <a:p>
+            <a:pPr algn="ctr"/>
+          </a:p>
+        </p:txBody>
+      </p:sp>
       <p:sp>
         <p:nvSpPr>
           <p:cNvPr id="5" name="TextBox 4"/>
@@ -8251,8 +7740,8 @@
         </p:nvSpPr>
         <p:spPr>
           <a:xfrm>
-            <a:off x="457200" y="5760720"/>
-            <a:ext cx="11430000" cy="548640"/>
+            <a:off x="457200" y="1417320"/>
+            <a:ext cx="5394960" cy="365760"/>
           </a:xfrm>
           <a:prstGeom prst="rect">
             <a:avLst/>
@@ -8266,15 +7755,541 @@
           <a:lstStyle/>
           <a:p>
             <a:pPr algn="l">
-              <a:defRPr sz="1500" b="1" i="1">
-                <a:solidFill>
-                  <a:srgbClr val="2E75B6"/>
-                </a:solidFill>
-                <a:latin typeface="Calibri"/>
-              </a:defRPr>
-            </a:pPr>
-            <a:r>
-              <a:t>Total ~2 semanas. Quais priorizar nas ~4 semanas restantes?</a:t>
+              <a:defRPr sz="1600" b="1" i="0">
+                <a:solidFill>
+                  <a:srgbClr val="1B5E20"/>
+                </a:solidFill>
+                <a:latin typeface="Calibri"/>
+              </a:defRPr>
+            </a:pPr>
+            <a:r>
+              <a:t>Exp 1: Sweep Dimensional (1440 runs)</a:t>
+            </a:r>
+          </a:p>
+        </p:txBody>
+      </p:sp>
+      <p:sp>
+        <p:nvSpPr>
+          <p:cNvPr id="6" name="TextBox 5"/>
+          <p:cNvSpPr txBox="1"/>
+          <p:nvPr/>
+        </p:nvSpPr>
+        <p:spPr>
+          <a:xfrm>
+            <a:off x="457200" y="1920240"/>
+            <a:ext cx="5394960" cy="2286000"/>
+          </a:xfrm>
+          <a:prstGeom prst="rect">
+            <a:avLst/>
+          </a:prstGeom>
+          <a:noFill/>
+        </p:spPr>
+        <p:txBody>
+          <a:bodyPr wrap="square">
+            <a:spAutoFit/>
+          </a:bodyPr>
+          <a:lstStyle/>
+          <a:p>
+            <a:pPr algn="l">
+              <a:defRPr sz="1300" b="0" i="0">
+                <a:solidFill>
+                  <a:srgbClr val="404040"/>
+                </a:solidFill>
+                <a:latin typeface="Calibri"/>
+              </a:defRPr>
+            </a:pPr>
+            <a:r>
+              <a:t>Com r₀≥1.0 (guard neutralizado):</a:t>
+            </a:r>
+          </a:p>
+          <a:p>
+            <a:pPr algn="l">
+              <a:spcBef>
+                <a:spcPts val="300"/>
+              </a:spcBef>
+              <a:defRPr sz="1300" b="0" i="0">
+                <a:solidFill>
+                  <a:srgbClr val="404040"/>
+                </a:solidFill>
+                <a:latin typeface="Calibri"/>
+              </a:defRPr>
+            </a:pPr>
+            <a:r>
+              <a:t>  V0 FPR = 0% em QUALQUER d</a:t>
+            </a:r>
+          </a:p>
+          <a:p>
+            <a:pPr algn="l">
+              <a:spcBef>
+                <a:spcPts val="300"/>
+              </a:spcBef>
+              <a:defRPr sz="1300" b="1" i="0">
+                <a:solidFill>
+                  <a:srgbClr val="1B5E20"/>
+                </a:solidFill>
+                <a:latin typeface="Calibri"/>
+              </a:defRPr>
+            </a:pPr>
+            <a:r>
+              <a:t>  → Chebyshev auto-cancela (CONFIRMADO)</a:t>
+            </a:r>
+          </a:p>
+          <a:p>
+            <a:pPr algn="l">
+              <a:spcBef>
+                <a:spcPts val="300"/>
+              </a:spcBef>
+              <a:defRPr sz="1300" b="0" i="0">
+                <a:solidFill>
+                  <a:srgbClr val="404040"/>
+                </a:solidFill>
+                <a:latin typeface="Calibri"/>
+              </a:defRPr>
+            </a:pPr>
+          </a:p>
+          <a:p>
+            <a:pPr algn="l">
+              <a:spcBef>
+                <a:spcPts val="300"/>
+              </a:spcBef>
+              <a:defRPr sz="1300" b="0" i="0">
+                <a:solidFill>
+                  <a:srgbClr val="404040"/>
+                </a:solidFill>
+                <a:latin typeface="Calibri"/>
+              </a:defRPr>
+            </a:pPr>
+            <a:r>
+              <a:t>Com r₀=0.001 (mal calibrado):</a:t>
+            </a:r>
+          </a:p>
+          <a:p>
+            <a:pPr algn="l">
+              <a:spcBef>
+                <a:spcPts val="300"/>
+              </a:spcBef>
+              <a:defRPr sz="1300" b="0" i="0">
+                <a:solidFill>
+                  <a:srgbClr val="404040"/>
+                </a:solidFill>
+                <a:latin typeface="Calibri"/>
+              </a:defRPr>
+            </a:pPr>
+            <a:r>
+              <a:t>  V0 FPR = 72-99.8% em todo d</a:t>
+            </a:r>
+          </a:p>
+          <a:p>
+            <a:pPr algn="l">
+              <a:spcBef>
+                <a:spcPts val="300"/>
+              </a:spcBef>
+              <a:defRPr sz="1300" b="1" i="0">
+                <a:solidFill>
+                  <a:srgbClr val="1B5E20"/>
+                </a:solidFill>
+                <a:latin typeface="Calibri"/>
+              </a:defRPr>
+            </a:pPr>
+            <a:r>
+              <a:t>  → Guard n&lt;3 domina tudo</a:t>
+            </a:r>
+          </a:p>
+          <a:p>
+            <a:pPr algn="l">
+              <a:spcBef>
+                <a:spcPts val="300"/>
+              </a:spcBef>
+              <a:defRPr sz="1300" b="0" i="0">
+                <a:solidFill>
+                  <a:srgbClr val="404040"/>
+                </a:solidFill>
+                <a:latin typeface="Calibri"/>
+              </a:defRPr>
+            </a:pPr>
+          </a:p>
+          <a:p>
+            <a:pPr algn="l">
+              <a:spcBef>
+                <a:spcPts val="300"/>
+              </a:spcBef>
+              <a:defRPr sz="1300" b="0" i="0">
+                <a:solidFill>
+                  <a:srgbClr val="404040"/>
+                </a:solidFill>
+                <a:latin typeface="Calibri"/>
+              </a:defRPr>
+            </a:pPr>
+            <a:r>
+              <a:t>V7 estável ~0.1% em TODOS os r₀ e d</a:t>
+            </a:r>
+          </a:p>
+        </p:txBody>
+      </p:sp>
+      <p:sp>
+        <p:nvSpPr>
+          <p:cNvPr id="7" name="Rounded Rectangle 6"/>
+          <p:cNvSpPr/>
+          <p:nvPr/>
+        </p:nvSpPr>
+        <p:spPr>
+          <a:xfrm>
+            <a:off x="6217920" y="1371600"/>
+            <a:ext cx="5760720" cy="3200400"/>
+          </a:xfrm>
+          <a:prstGeom prst="roundRect">
+            <a:avLst/>
+          </a:prstGeom>
+          <a:solidFill>
+            <a:srgbClr val="FDEDED"/>
+          </a:solidFill>
+          <a:ln w="19050">
+            <a:solidFill>
+              <a:srgbClr val="E74C3C"/>
+            </a:solidFill>
+          </a:ln>
+        </p:spPr>
+        <p:style>
+          <a:lnRef idx="1">
+            <a:schemeClr val="accent1"/>
+          </a:lnRef>
+          <a:fillRef idx="3">
+            <a:schemeClr val="accent1"/>
+          </a:fillRef>
+          <a:effectRef idx="2">
+            <a:schemeClr val="accent1"/>
+          </a:effectRef>
+          <a:fontRef idx="minor">
+            <a:schemeClr val="lt1"/>
+          </a:fontRef>
+        </p:style>
+        <p:txBody>
+          <a:bodyPr rtlCol="0" anchor="ctr"/>
+          <a:lstStyle/>
+          <a:p>
+            <a:pPr algn="ctr"/>
+          </a:p>
+        </p:txBody>
+      </p:sp>
+      <p:sp>
+        <p:nvSpPr>
+          <p:cNvPr id="8" name="TextBox 7"/>
+          <p:cNvSpPr txBox="1"/>
+          <p:nvPr/>
+        </p:nvSpPr>
+        <p:spPr>
+          <a:xfrm>
+            <a:off x="6400800" y="1417320"/>
+            <a:ext cx="5394960" cy="365760"/>
+          </a:xfrm>
+          <a:prstGeom prst="rect">
+            <a:avLst/>
+          </a:prstGeom>
+          <a:noFill/>
+        </p:spPr>
+        <p:txBody>
+          <a:bodyPr wrap="square">
+            <a:spAutoFit/>
+          </a:bodyPr>
+          <a:lstStyle/>
+          <a:p>
+            <a:pPr algn="l">
+              <a:defRPr sz="1600" b="1" i="0">
+                <a:solidFill>
+                  <a:srgbClr val="E74C3C"/>
+                </a:solidFill>
+                <a:latin typeface="Calibri"/>
+              </a:defRPr>
+            </a:pPr>
+            <a:r>
+              <a:t>Exp 2: Ablação V0-V7 (240 runs, d=17)</a:t>
+            </a:r>
+          </a:p>
+        </p:txBody>
+      </p:sp>
+      <p:sp>
+        <p:nvSpPr>
+          <p:cNvPr id="9" name="TextBox 8"/>
+          <p:cNvSpPr txBox="1"/>
+          <p:nvPr/>
+        </p:nvSpPr>
+        <p:spPr>
+          <a:xfrm>
+            <a:off x="6400800" y="1920240"/>
+            <a:ext cx="5394960" cy="2286000"/>
+          </a:xfrm>
+          <a:prstGeom prst="rect">
+            <a:avLst/>
+          </a:prstGeom>
+          <a:noFill/>
+        </p:spPr>
+        <p:txBody>
+          <a:bodyPr wrap="square">
+            <a:spAutoFit/>
+          </a:bodyPr>
+          <a:lstStyle/>
+          <a:p>
+            <a:pPr algn="l">
+              <a:defRPr sz="1300" b="0" i="0">
+                <a:solidFill>
+                  <a:srgbClr val="404040"/>
+                </a:solidFill>
+                <a:latin typeface="Calibri"/>
+              </a:defRPr>
+            </a:pPr>
+            <a:r>
+              <a:t>V7 (full):     FPR = 0.1%  ✓</a:t>
+            </a:r>
+          </a:p>
+          <a:p>
+            <a:pPr algn="l">
+              <a:spcBef>
+                <a:spcPts val="300"/>
+              </a:spcBef>
+              <a:defRPr sz="1300" b="0" i="0">
+                <a:solidFill>
+                  <a:srgbClr val="1B5E20"/>
+                </a:solidFill>
+                <a:latin typeface="Calibri"/>
+              </a:defRPr>
+            </a:pPr>
+            <a:r>
+              <a:t>V0 (original): FPR = 0%    ✓ (r₀=1.0)</a:t>
+            </a:r>
+          </a:p>
+          <a:p>
+            <a:pPr algn="l">
+              <a:spcBef>
+                <a:spcPts val="300"/>
+              </a:spcBef>
+              <a:defRPr sz="1300" b="0" i="0">
+                <a:solidFill>
+                  <a:srgbClr val="1B5E20"/>
+                </a:solidFill>
+                <a:latin typeface="Calibri"/>
+              </a:defRPr>
+            </a:pPr>
+            <a:r>
+              <a:t>V5 (guard n1): FPR = 0.4%  ✓</a:t>
+            </a:r>
+          </a:p>
+          <a:p>
+            <a:pPr algn="l">
+              <a:spcBef>
+                <a:spcPts val="300"/>
+              </a:spcBef>
+              <a:defRPr sz="1300" b="0" i="0">
+                <a:solidFill>
+                  <a:srgbClr val="404040"/>
+                </a:solidFill>
+                <a:latin typeface="Calibri"/>
+              </a:defRPr>
+            </a:pPr>
+          </a:p>
+          <a:p>
+            <a:pPr algn="l">
+              <a:spcBef>
+                <a:spcPts val="300"/>
+              </a:spcBef>
+              <a:defRPr sz="1300" b="0" i="0">
+                <a:solidFill>
+                  <a:srgbClr val="E74C3C"/>
+                </a:solidFill>
+                <a:latin typeface="Calibri"/>
+              </a:defRPr>
+            </a:pPr>
+            <a:r>
+              <a:t>V2 (ecc only): FPR = 49.7% ✗</a:t>
+            </a:r>
+          </a:p>
+          <a:p>
+            <a:pPr algn="l">
+              <a:spcBef>
+                <a:spcPts val="300"/>
+              </a:spcBef>
+              <a:defRPr sz="1300" b="0" i="0">
+                <a:solidFill>
+                  <a:srgbClr val="E74C3C"/>
+                </a:solidFill>
+                <a:latin typeface="Calibri"/>
+              </a:defRPr>
+            </a:pPr>
+            <a:r>
+              <a:t>V1 (Welford):  FPR = 98.9% ✗✗</a:t>
+            </a:r>
+          </a:p>
+          <a:p>
+            <a:pPr algn="l">
+              <a:spcBef>
+                <a:spcPts val="300"/>
+              </a:spcBef>
+              <a:defRPr sz="1300" b="0" i="0">
+                <a:solidFill>
+                  <a:srgbClr val="E74C3C"/>
+                </a:solidFill>
+                <a:latin typeface="Calibri"/>
+              </a:defRPr>
+            </a:pPr>
+            <a:r>
+              <a:t>V3 (Welf+ecc): FPR = 99.8% ✗✗✗</a:t>
+            </a:r>
+          </a:p>
+          <a:p>
+            <a:pPr algn="l">
+              <a:spcBef>
+                <a:spcPts val="300"/>
+              </a:spcBef>
+              <a:defRPr sz="1300" b="0" i="0">
+                <a:solidFill>
+                  <a:srgbClr val="404040"/>
+                </a:solidFill>
+                <a:latin typeface="Calibri"/>
+              </a:defRPr>
+            </a:pPr>
+          </a:p>
+          <a:p>
+            <a:pPr algn="l">
+              <a:spcBef>
+                <a:spcPts val="300"/>
+              </a:spcBef>
+              <a:defRPr sz="1300" b="1" i="0">
+                <a:solidFill>
+                  <a:srgbClr val="E74C3C"/>
+                </a:solidFill>
+                <a:latin typeface="Calibri"/>
+              </a:defRPr>
+            </a:pPr>
+            <a:r>
+              <a:t>Welford SOZINHO piora!</a:t>
+            </a:r>
+          </a:p>
+          <a:p>
+            <a:pPr algn="l">
+              <a:spcBef>
+                <a:spcPts val="300"/>
+              </a:spcBef>
+              <a:defRPr sz="1300" b="1" i="0">
+                <a:solidFill>
+                  <a:srgbClr val="E74C3C"/>
+                </a:solidFill>
+                <a:latin typeface="Calibri"/>
+              </a:defRPr>
+            </a:pPr>
+            <a:r>
+              <a:t>Adaptações são ACOPLADAS</a:t>
+            </a:r>
+          </a:p>
+        </p:txBody>
+      </p:sp>
+      <p:sp>
+        <p:nvSpPr>
+          <p:cNvPr id="10" name="Rounded Rectangle 9"/>
+          <p:cNvSpPr/>
+          <p:nvPr/>
+        </p:nvSpPr>
+        <p:spPr>
+          <a:xfrm>
+            <a:off x="274320" y="4754880"/>
+            <a:ext cx="11704320" cy="1645920"/>
+          </a:xfrm>
+          <a:prstGeom prst="roundRect">
+            <a:avLst/>
+          </a:prstGeom>
+          <a:solidFill>
+            <a:srgbClr val="F5F5F5"/>
+          </a:solidFill>
+          <a:ln w="12700">
+            <a:solidFill>
+              <a:srgbClr val="404040"/>
+            </a:solidFill>
+          </a:ln>
+        </p:spPr>
+        <p:style>
+          <a:lnRef idx="1">
+            <a:schemeClr val="accent1"/>
+          </a:lnRef>
+          <a:fillRef idx="3">
+            <a:schemeClr val="accent1"/>
+          </a:fillRef>
+          <a:effectRef idx="2">
+            <a:schemeClr val="accent1"/>
+          </a:effectRef>
+          <a:fontRef idx="minor">
+            <a:schemeClr val="lt1"/>
+          </a:fontRef>
+        </p:style>
+        <p:txBody>
+          <a:bodyPr rtlCol="0" anchor="ctr"/>
+          <a:lstStyle/>
+          <a:p>
+            <a:pPr algn="ctr"/>
+          </a:p>
+        </p:txBody>
+      </p:sp>
+      <p:sp>
+        <p:nvSpPr>
+          <p:cNvPr id="11" name="TextBox 10"/>
+          <p:cNvSpPr txBox="1"/>
+          <p:nvPr/>
+        </p:nvSpPr>
+        <p:spPr>
+          <a:xfrm>
+            <a:off x="457200" y="4846320"/>
+            <a:ext cx="11338560" cy="365760"/>
+          </a:xfrm>
+          <a:prstGeom prst="rect">
+            <a:avLst/>
+          </a:prstGeom>
+          <a:noFill/>
+        </p:spPr>
+        <p:txBody>
+          <a:bodyPr wrap="square">
+            <a:spAutoFit/>
+          </a:bodyPr>
+          <a:lstStyle/>
+          <a:p>
+            <a:pPr algn="l">
+              <a:defRPr sz="1200" b="1" i="0">
+                <a:solidFill>
+                  <a:srgbClr val="1B3A5C"/>
+                </a:solidFill>
+                <a:latin typeface="Calibri"/>
+              </a:defRPr>
+            </a:pPr>
+            <a:r>
+              <a:t>Estatística: Friedman χ²=203.2, p&lt;10⁻⁴⁰ | ANOVA F=19381, p=0 | CD=1.917 (Neményi)</a:t>
+            </a:r>
+          </a:p>
+          <a:p>
+            <a:pPr algn="l">
+              <a:spcBef>
+                <a:spcPts val="800"/>
+              </a:spcBef>
+              <a:defRPr sz="1300" b="1" i="0">
+                <a:solidFill>
+                  <a:srgbClr val="F39C12"/>
+                </a:solidFill>
+                <a:latin typeface="Calibri"/>
+              </a:defRPr>
+            </a:pPr>
+            <a:r>
+              <a:t>Exp 3 (Baseline IF/OC-SVM): 42 runs rodando no Linux — resultados amanhã</a:t>
+            </a:r>
+          </a:p>
+          <a:p>
+            <a:pPr algn="l">
+              <a:spcBef>
+                <a:spcPts val="600"/>
+              </a:spcBef>
+              <a:defRPr sz="1200" b="0" i="1">
+                <a:solidFill>
+                  <a:srgbClr val="404040"/>
+                </a:solidFill>
+                <a:latin typeface="Calibri"/>
+              </a:defRPr>
+            </a:pPr>
+            <a:r>
+              <a:t>Achado principal: as adaptações formam um sistema acoplado. Ligar uma isoladamente pode PIORAR o resultado.</a:t>
             </a:r>
           </a:p>
         </p:txBody>
@@ -8336,7 +8351,7 @@
               </a:defRPr>
             </a:pPr>
             <a:r>
-              <a:t>Decisoes Necessarias</a:t>
+              <a:t>Próximos Passos e Decisões</a:t>
             </a:r>
           </a:p>
         </p:txBody>
@@ -8415,7 +8430,7 @@
               </a:defRPr>
             </a:pPr>
             <a:r>
-              <a:t>1. As 5 adaptacoes + prova do auto-cancelamento constituem contribuicao suficiente?</a:t>
+              <a:t>1. Auto-cancelamento + acoplamento + estudo empírico sustentam um paper SoftCom?</a:t>
             </a:r>
           </a:p>
         </p:txBody>
@@ -8494,7 +8509,7 @@
               </a:defRPr>
             </a:pPr>
             <a:r>
-              <a:t>2. Prioridade: sweep+ablation (fortalece paper) vs S5 Two-Stage (melhora resultados)?</a:t>
+              <a:t>2. Foco: análise dimensional pura OU incluir resultados de detecção IoT (F1=43.7%)?</a:t>
             </a:r>
           </a:p>
         </p:txBody>
@@ -8573,7 +8588,7 @@
               </a:defRPr>
             </a:pPr>
             <a:r>
-              <a:t>3. Escopo realista em ~4 semanas: paper focado no bug dimensional + dissertacao?</a:t>
+              <a:t>3. Timeline: paper SoftCom para quando? Dissertação para agosto?</a:t>
             </a:r>
           </a:p>
         </p:txBody>
@@ -8609,7 +8624,7 @@
               </a:defRPr>
             </a:pPr>
             <a:r>
-              <a:t>Obrigado. Abro para discussao.</a:t>
+              <a:t>Obrigado. Abro para discussão.</a:t>
             </a:r>
           </a:p>
         </p:txBody>

</xml_diff>

<commit_message>
update advisor presentations and bump SoftCom paper
- expand 2026-03-19 advisor deck to 22 slides with C01-C04 results,
  dimensional framework, and 5 technical adaptations from ablation study
- update 2026-04-17 main-advisor deck with r₀ scale-dependency finding
  and pseudocode showing 3 broken code paths (intersection, n<3 guard, life decay)
- bump writing/papers/SoftCom submodule to f1bdedc
  (HST/Kitsune baselines + placeholder updates)
- archive session progress logs from Apr 11, 14, 25, 26

Co-Authored-By: Claude Opus 4.7 (1M context) <noreply@anthropic.com>
</commit_message>
<xml_diff>
--- a/docs/meeting/2026-04-17-main-advisor/2026-04-17-main-advisor.pptx
+++ b/docs/meeting/2026-04-17-main-advisor/2026-04-17-main-advisor.pptx
@@ -4571,7 +4571,7 @@
               </a:defRPr>
             </a:pPr>
             <a:r>
-              <a:t>r₀=0.001 fixo em todos os 167 experimentos (robusto)</a:t>
+              <a:t>Maia 2020: r₀=0.001 fixo. Nós descobrimos: depende da escala dos dados</a:t>
             </a:r>
           </a:p>
         </p:txBody>
@@ -4705,23 +4705,44 @@
             </a:r>
             <a:br/>
             <a:r>
-              <a:t>    calcular ξᵢ(x) e ζᵢ(x)</a:t>
+              <a:t>    Sᵢ ← Sᵢ + 1</a:t>
             </a:r>
             <a:br/>
             <a:r>
-              <a:t>    mᵢ ← 3/(1+e^(-0.007(Sᵢ-100)))</a:t>
+              <a:t>    μ ← μ + (x−μ)/S       # média incremental</a:t>
             </a:r>
             <a:br/>
             <a:r>
-              <a:t>    thrᵢ ← (mᵢ²+1)/(2·Sᵢ)</a:t>
+              <a:t>    σ² ← atualizar(δ)    # ← BUG AQUI</a:t>
             </a:r>
             <a:br/>
             <a:r>
-              <a:t>    aceitaᵢ ← (ζᵢ ≤ thrᵢ)</a:t>
+              <a:t>    ξ ← 1/S + ‖x−μ‖²/(S·σ²)</a:t>
+            </a:r>
+            <a:br/>
+            <a:r>
+              <a:t>    ζ ← ξ/2</a:t>
             </a:r>
             <a:br/>
             <a:br/>
             <a:r>
+              <a:t>    se S &lt; 3:              # ← PATH 2</a:t>
+            </a:r>
+            <a:br/>
+            <a:r>
+              <a:t>      outlier ← (σ² &gt; r₀)</a:t>
+            </a:r>
+            <a:br/>
+            <a:r>
+              <a:t>    senão:               # Chebyshev OK</a:t>
+            </a:r>
+            <a:br/>
+            <a:r>
+              <a:t>      outlier ← (ζ &gt; thr)</a:t>
+            </a:r>
+            <a:br/>
+            <a:br/>
+            <a:r>
               <a:t>  se algum aceita:</a:t>
             </a:r>
             <a:br/>
@@ -4731,6 +4752,14 @@
             <a:br/>
             <a:r>
               <a:t>    atualizar best: μ, σ², S</a:t>
+            </a:r>
+            <a:br/>
+            <a:r>
+              <a:t>    life += (√σ²−dist)/√σ²  # ← PATH 3</a:t>
+            </a:r>
+            <a:br/>
+            <a:r>
+              <a:t>    merge se dist &lt; 2(√σ²) # ← PATH 1</a:t>
             </a:r>
             <a:br/>
             <a:r>

</xml_diff>